<commit_message>
refactor: anydoc/htmd for docs, slim ebooks
Replace hand parsers with anydoc→MD and htmd; drop dead
office/pdf/config scrapers so previews stay one MD path.

Co-authored-by: Cursor <cursoragent@cursor.com>
</commit_message>
<xml_diff>
--- a/demo/files/sample.pptx
+++ b/demo/files/sample.pptx
@@ -1,13 +1,55 @@
+
+<file path=ppt/presentation.xml><?xml version="1.0" encoding="utf-8"?>
+<p:presentation xmlns:a="http://schemas.openxmlformats.org/drawingml/2006/main" xmlns:p="http://schemas.openxmlformats.org/presentationml/2006/main" xmlns:r="http://schemas.openxmlformats.org/officeDocument/2006/relationships">
+  <p:sldIdLst>
+    <p:sldId id="256" r:id="rId1"/>
+    <p:sldId id="257" r:id="rId2"/>
+  </p:sldIdLst>
+</p:presentation>
+</file>
 
 <file path=ppt/slides/slide1.xml><?xml version="1.0" encoding="utf-8"?>
-<p:sld xmlns:a="http://schemas.openxmlformats.org/drawingml/2006/main" xmlns:p="http://schemas.openxmlformats.org/presentationml/2006/main">
+<p:sld xmlns:a="http://schemas.openxmlformats.org/drawingml/2006/main" xmlns:p="http://schemas.openxmlformats.org/presentationml/2006/main" xmlns:r="http://schemas.openxmlformats.org/officeDocument/2006/relationships">
   <p:cSld>
     <p:spTree>
+      <p:nvGrpSpPr>
+        <p:cNvPr id="1" name=""/>
+        <p:cNvGrpSpPr/>
+        <p:nvPr/>
+      </p:nvGrpSpPr>
+      <p:grpSpPr/>
       <p:sp>
+        <p:nvSpPr>
+          <p:cNvPr id="2" name="Title"/>
+          <p:cNvSpPr/>
+          <p:nvPr>
+            <p:ph type="title"/>
+          </p:nvPr>
+        </p:nvSpPr>
+        <p:spPr/>
         <p:txBody>
+          <a:bodyPr/>
           <a:p>
             <a:r>
               <a:t>Slide 1 — omnicat PPTX demo</a:t>
+            </a:r>
+          </a:p>
+        </p:txBody>
+      </p:sp>
+      <p:sp>
+        <p:nvSpPr>
+          <p:cNvPr id="3" name="Body"/>
+          <p:cNvSpPr/>
+          <p:nvPr>
+            <p:ph idx="1"/>
+          </p:nvPr>
+        </p:nvSpPr>
+        <p:spPr/>
+        <p:txBody>
+          <a:bodyPr/>
+          <a:p>
+            <a:r>
+              <a:t>First slide body for preview.</a:t>
             </a:r>
           </a:p>
         </p:txBody>
@@ -18,14 +60,47 @@
 </file>
 
 <file path=ppt/slides/slide2.xml><?xml version="1.0" encoding="utf-8"?>
-<p:sld xmlns:a="http://schemas.openxmlformats.org/drawingml/2006/main" xmlns:p="http://schemas.openxmlformats.org/presentationml/2006/main">
+<p:sld xmlns:a="http://schemas.openxmlformats.org/drawingml/2006/main" xmlns:p="http://schemas.openxmlformats.org/presentationml/2006/main" xmlns:r="http://schemas.openxmlformats.org/officeDocument/2006/relationships">
   <p:cSld>
     <p:spTree>
+      <p:nvGrpSpPr>
+        <p:cNvPr id="1" name=""/>
+        <p:cNvGrpSpPr/>
+        <p:nvPr/>
+      </p:nvGrpSpPr>
+      <p:grpSpPr/>
       <p:sp>
+        <p:nvSpPr>
+          <p:cNvPr id="2" name="Title"/>
+          <p:cNvSpPr/>
+          <p:nvPr>
+            <p:ph type="title"/>
+          </p:nvPr>
+        </p:nvSpPr>
+        <p:spPr/>
         <p:txBody>
+          <a:bodyPr/>
           <a:p>
             <a:r>
               <a:t>Slide 2 — omnicat PPTX demo</a:t>
+            </a:r>
+          </a:p>
+        </p:txBody>
+      </p:sp>
+      <p:sp>
+        <p:nvSpPr>
+          <p:cNvPr id="3" name="Body"/>
+          <p:cNvSpPr/>
+          <p:nvPr>
+            <p:ph idx="1"/>
+          </p:nvPr>
+        </p:nvSpPr>
+        <p:spPr/>
+        <p:txBody>
+          <a:bodyPr/>
+          <a:p>
+            <a:r>
+              <a:t>Second slide body for preview.</a:t>
             </a:r>
           </a:p>
         </p:txBody>

</xml_diff>